<commit_message>
docs: Initialize wiki repository, add new project documents, and update existing research, system analysis, and GitHub analysis wiki pages.
</commit_message>
<xml_diff>
--- a/docs/주제1_5팀_PBL최종_제출자료.pptx
+++ b/docs/주제1_5팀_PBL최종_제출자료.pptx
@@ -14238,49 +14238,6 @@
       </p:sp>
       <p:sp>
         <p:nvSpPr>
-          <p:cNvPr id="17" name="TextBox 16"/>
-          <p:cNvSpPr txBox="1"/>
-          <p:nvPr/>
-        </p:nvSpPr>
-        <p:spPr>
-          <a:xfrm>
-            <a:off x="457200" y="6583680"/>
-            <a:ext cx="10972800" cy="246221"/>
-          </a:xfrm>
-          <a:prstGeom prst="rect">
-            <a:avLst/>
-          </a:prstGeom>
-          <a:noFill/>
-        </p:spPr>
-        <p:txBody>
-          <a:bodyPr wrap="square">
-            <a:spAutoFit/>
-          </a:bodyPr>
-          <a:lstStyle/>
-          <a:p>
-            <a:pPr lvl="0" algn="r">
-              <a:defRPr sz="1000" b="0">
-                <a:solidFill>
-                  <a:srgbClr val="808080"/>
-                </a:solidFill>
-              </a:defRPr>
-            </a:pPr>
-            <a:r>
-              <a:rPr>
-                <a:latin typeface="현대하모니 L"/>
-                <a:ea typeface="현대하모니 L"/>
-              </a:rPr>
-              <a:t>MOBIUS BOOTCAMP 1기 | PBL 결과발표 | 6/10</a:t>
-            </a:r>
-            <a:endParaRPr>
-              <a:latin typeface="현대하모니 L"/>
-              <a:ea typeface="현대하모니 L"/>
-            </a:endParaRPr>
-          </a:p>
-        </p:txBody>
-      </p:sp>
-      <p:sp>
-        <p:nvSpPr>
           <p:cNvPr id="6" name="Rounded Rectangle 5"/>
           <p:cNvSpPr/>
           <p:nvPr/>
@@ -14385,14 +14342,115 @@
       </p:sp>
       <p:sp>
         <p:nvSpPr>
-          <p:cNvPr id="28" name="TextBox 21"/>
+          <p:cNvPr id="22" name="TextBox 21"/>
           <p:cNvSpPr txBox="1"/>
           <p:nvPr/>
         </p:nvSpPr>
         <p:spPr>
           <a:xfrm>
-            <a:off x="6643053" y="2514600"/>
-            <a:ext cx="274320" cy="264795"/>
+            <a:off x="457200" y="1371600"/>
+            <a:ext cx="5486400" cy="457200"/>
+          </a:xfrm>
+          <a:prstGeom prst="rect">
+            <a:avLst/>
+          </a:prstGeom>
+          <a:noFill/>
+        </p:spPr>
+        <p:txBody>
+          <a:bodyPr wrap="none">
+            <a:spAutoFit/>
+          </a:bodyPr>
+          <a:lstStyle/>
+          <a:p>
+            <a:pPr>
+              <a:defRPr b="1" sz="2200">
+                <a:solidFill>
+                  <a:srgbClr val="003366"/>
+                </a:solidFill>
+              </a:defRPr>
+            </a:pPr>
+            <a:r>
+              <a:t>아키텍처 (Architecture)</a:t>
+            </a:r>
+          </a:p>
+        </p:txBody>
+      </p:sp>
+      <p:sp>
+        <p:nvSpPr>
+          <p:cNvPr id="23" name="Rounded Rectangle 22"/>
+          <p:cNvSpPr/>
+          <p:nvPr/>
+        </p:nvSpPr>
+        <p:spPr>
+          <a:xfrm>
+            <a:off x="457200" y="2286000"/>
+            <a:ext cx="1828800" cy="914400"/>
+          </a:xfrm>
+          <a:prstGeom prst="roundRect">
+            <a:avLst/>
+          </a:prstGeom>
+          <a:solidFill>
+            <a:srgbClr val="DCE6F2"/>
+          </a:solidFill>
+          <a:ln>
+            <a:solidFill>
+              <a:srgbClr val="4F81BD"/>
+            </a:solidFill>
+          </a:ln>
+        </p:spPr>
+        <p:style>
+          <a:lnRef idx="1">
+            <a:schemeClr val="accent1"/>
+          </a:lnRef>
+          <a:fillRef idx="3">
+            <a:schemeClr val="accent1"/>
+          </a:fillRef>
+          <a:effectRef idx="2">
+            <a:schemeClr val="accent1"/>
+          </a:effectRef>
+          <a:fontRef idx="minor">
+            <a:schemeClr val="lt1"/>
+          </a:fontRef>
+        </p:style>
+        <p:txBody>
+          <a:bodyPr rtlCol="0" anchor="ctr"/>
+          <a:lstStyle/>
+          <a:p>
+            <a:pPr>
+              <a:defRPr b="1" sz="1400">
+                <a:solidFill>
+                  <a:srgbClr val="000000"/>
+                </a:solidFill>
+              </a:defRPr>
+            </a:pPr>
+            <a:r>
+              <a:t>데이터 입력 (Sensor)</a:t>
+            </a:r>
+          </a:p>
+          <a:p>
+            <a:pPr>
+              <a:defRPr sz="1200">
+                <a:solidFill>
+                  <a:srgbClr val="000000"/>
+                </a:solidFill>
+              </a:defRPr>
+            </a:pPr>
+            <a:r>
+              <a:t>Radar / Ultrasonic</a:t>
+            </a:r>
+          </a:p>
+        </p:txBody>
+      </p:sp>
+      <p:sp>
+        <p:nvSpPr>
+          <p:cNvPr id="24" name="TextBox 23"/>
+          <p:cNvSpPr txBox="1"/>
+          <p:nvPr/>
+        </p:nvSpPr>
+        <p:spPr>
+          <a:xfrm>
+            <a:off x="365760" y="3291840"/>
+            <a:ext cx="2011680" cy="914400"/>
           </a:xfrm>
           <a:prstGeom prst="rect">
             <a:avLst/>
@@ -14404,29 +14462,134 @@
             <a:spAutoFit/>
           </a:bodyPr>
           <a:lstStyle/>
-          <a:p>
-            <a:pPr lvl="0" algn="l">
-              <a:defRPr/>
+          <a:p/>
+          <a:p>
+            <a:pPr>
+              <a:defRPr sz="1200"/>
             </a:pPr>
-            <a:endParaRPr sz="1200" b="1">
-              <a:solidFill>
-                <a:srgbClr val="00c853"/>
-              </a:solidFill>
-              <a:latin typeface="Segoe UI Symbol"/>
-            </a:endParaRPr>
-          </a:p>
-        </p:txBody>
-      </p:sp>
-      <p:sp>
-        <p:nvSpPr>
-          <p:cNvPr id="36" name="TextBox 29"/>
+            <a:r>
+              <a:t>• ISO 26262 ASIL B</a:t>
+            </a:r>
+            <a:br/>
+            <a:r>
+              <a:t>• HW Fault Detection</a:t>
+            </a:r>
+          </a:p>
+        </p:txBody>
+      </p:sp>
+      <p:sp>
+        <p:nvSpPr>
+          <p:cNvPr id="25" name="Right Arrow 24"/>
+          <p:cNvSpPr/>
+          <p:nvPr/>
+        </p:nvSpPr>
+        <p:spPr>
+          <a:xfrm>
+            <a:off x="2377440" y="2560320"/>
+            <a:ext cx="548640" cy="365760"/>
+          </a:xfrm>
+          <a:prstGeom prst="rightArrow">
+            <a:avLst/>
+          </a:prstGeom>
+        </p:spPr>
+        <p:style>
+          <a:lnRef idx="1">
+            <a:schemeClr val="accent1"/>
+          </a:lnRef>
+          <a:fillRef idx="3">
+            <a:schemeClr val="accent1"/>
+          </a:fillRef>
+          <a:effectRef idx="2">
+            <a:schemeClr val="accent1"/>
+          </a:effectRef>
+          <a:fontRef idx="minor">
+            <a:schemeClr val="lt1"/>
+          </a:fontRef>
+        </p:style>
+        <p:txBody>
+          <a:bodyPr rtlCol="0" anchor="ctr"/>
+          <a:lstStyle/>
+          <a:p>
+            <a:pPr algn="ctr"/>
+          </a:p>
+        </p:txBody>
+      </p:sp>
+      <p:sp>
+        <p:nvSpPr>
+          <p:cNvPr id="26" name="Rounded Rectangle 25"/>
+          <p:cNvSpPr/>
+          <p:nvPr/>
+        </p:nvSpPr>
+        <p:spPr>
+          <a:xfrm>
+            <a:off x="3017520" y="2286000"/>
+            <a:ext cx="1828800" cy="914400"/>
+          </a:xfrm>
+          <a:prstGeom prst="roundRect">
+            <a:avLst/>
+          </a:prstGeom>
+          <a:solidFill>
+            <a:srgbClr val="FDE9D9"/>
+          </a:solidFill>
+          <a:ln>
+            <a:solidFill>
+              <a:srgbClr val="F79646"/>
+            </a:solidFill>
+          </a:ln>
+        </p:spPr>
+        <p:style>
+          <a:lnRef idx="1">
+            <a:schemeClr val="accent1"/>
+          </a:lnRef>
+          <a:fillRef idx="3">
+            <a:schemeClr val="accent1"/>
+          </a:fillRef>
+          <a:effectRef idx="2">
+            <a:schemeClr val="accent1"/>
+          </a:effectRef>
+          <a:fontRef idx="minor">
+            <a:schemeClr val="lt1"/>
+          </a:fontRef>
+        </p:style>
+        <p:txBody>
+          <a:bodyPr rtlCol="0" anchor="ctr"/>
+          <a:lstStyle/>
+          <a:p>
+            <a:pPr>
+              <a:defRPr b="1" sz="1400">
+                <a:solidFill>
+                  <a:srgbClr val="000000"/>
+                </a:solidFill>
+              </a:defRPr>
+            </a:pPr>
+            <a:r>
+              <a:t>제어 판단 (ECU)</a:t>
+            </a:r>
+          </a:p>
+          <a:p>
+            <a:pPr>
+              <a:defRPr sz="1200">
+                <a:solidFill>
+                  <a:srgbClr val="000000"/>
+                </a:solidFill>
+              </a:defRPr>
+            </a:pPr>
+            <a:r>
+              <a:t>F-07/F-08 Logic</a:t>
+            </a:r>
+          </a:p>
+        </p:txBody>
+      </p:sp>
+      <p:sp>
+        <p:nvSpPr>
+          <p:cNvPr id="27" name="TextBox 26"/>
           <p:cNvSpPr txBox="1"/>
           <p:nvPr/>
         </p:nvSpPr>
         <p:spPr>
           <a:xfrm>
-            <a:off x="6643053" y="3063240"/>
-            <a:ext cx="274320" cy="274320"/>
+            <a:off x="2926080" y="3291840"/>
+            <a:ext cx="2011680" cy="914400"/>
           </a:xfrm>
           <a:prstGeom prst="rect">
             <a:avLst/>
@@ -14438,29 +14601,134 @@
             <a:spAutoFit/>
           </a:bodyPr>
           <a:lstStyle/>
-          <a:p>
-            <a:pPr lvl="0" algn="l">
-              <a:defRPr/>
+          <a:p/>
+          <a:p>
+            <a:pPr>
+              <a:defRPr sz="1200"/>
             </a:pPr>
-            <a:endParaRPr sz="1200" b="1">
-              <a:solidFill>
-                <a:srgbClr val="00c853"/>
-              </a:solidFill>
-              <a:latin typeface="Segoe UI Symbol"/>
-            </a:endParaRPr>
-          </a:p>
-        </p:txBody>
-      </p:sp>
-      <p:sp>
-        <p:nvSpPr>
-          <p:cNvPr id="40" name="TextBox 33"/>
+            <a:r>
+              <a:t>• A-SPICE SWE.2</a:t>
+            </a:r>
+            <a:br/>
+            <a:r>
+              <a:t>• Risk Eval &amp; Protection</a:t>
+            </a:r>
+          </a:p>
+        </p:txBody>
+      </p:sp>
+      <p:sp>
+        <p:nvSpPr>
+          <p:cNvPr id="28" name="Right Arrow 27"/>
+          <p:cNvSpPr/>
+          <p:nvPr/>
+        </p:nvSpPr>
+        <p:spPr>
+          <a:xfrm>
+            <a:off x="4937760" y="2560320"/>
+            <a:ext cx="548640" cy="365760"/>
+          </a:xfrm>
+          <a:prstGeom prst="rightArrow">
+            <a:avLst/>
+          </a:prstGeom>
+        </p:spPr>
+        <p:style>
+          <a:lnRef idx="1">
+            <a:schemeClr val="accent1"/>
+          </a:lnRef>
+          <a:fillRef idx="3">
+            <a:schemeClr val="accent1"/>
+          </a:fillRef>
+          <a:effectRef idx="2">
+            <a:schemeClr val="accent1"/>
+          </a:effectRef>
+          <a:fontRef idx="minor">
+            <a:schemeClr val="lt1"/>
+          </a:fontRef>
+        </p:style>
+        <p:txBody>
+          <a:bodyPr rtlCol="0" anchor="ctr"/>
+          <a:lstStyle/>
+          <a:p>
+            <a:pPr algn="ctr"/>
+          </a:p>
+        </p:txBody>
+      </p:sp>
+      <p:sp>
+        <p:nvSpPr>
+          <p:cNvPr id="29" name="Rounded Rectangle 28"/>
+          <p:cNvSpPr/>
+          <p:nvPr/>
+        </p:nvSpPr>
+        <p:spPr>
+          <a:xfrm>
+            <a:off x="5577840" y="2286000"/>
+            <a:ext cx="1828800" cy="914400"/>
+          </a:xfrm>
+          <a:prstGeom prst="roundRect">
+            <a:avLst/>
+          </a:prstGeom>
+          <a:solidFill>
+            <a:srgbClr val="EBF1DE"/>
+          </a:solidFill>
+          <a:ln>
+            <a:solidFill>
+              <a:srgbClr val="9BBB59"/>
+            </a:solidFill>
+          </a:ln>
+        </p:spPr>
+        <p:style>
+          <a:lnRef idx="1">
+            <a:schemeClr val="accent1"/>
+          </a:lnRef>
+          <a:fillRef idx="3">
+            <a:schemeClr val="accent1"/>
+          </a:fillRef>
+          <a:effectRef idx="2">
+            <a:schemeClr val="accent1"/>
+          </a:effectRef>
+          <a:fontRef idx="minor">
+            <a:schemeClr val="lt1"/>
+          </a:fontRef>
+        </p:style>
+        <p:txBody>
+          <a:bodyPr rtlCol="0" anchor="ctr"/>
+          <a:lstStyle/>
+          <a:p>
+            <a:pPr>
+              <a:defRPr b="1" sz="1400">
+                <a:solidFill>
+                  <a:srgbClr val="000000"/>
+                </a:solidFill>
+              </a:defRPr>
+            </a:pPr>
+            <a:r>
+              <a:t>최종 출력 (Actuator)</a:t>
+            </a:r>
+          </a:p>
+          <a:p>
+            <a:pPr>
+              <a:defRPr sz="1200">
+                <a:solidFill>
+                  <a:srgbClr val="000000"/>
+                </a:solidFill>
+              </a:defRPr>
+            </a:pPr>
+            <a:r>
+              <a:t>Child Lock Motor</a:t>
+            </a:r>
+          </a:p>
+        </p:txBody>
+      </p:sp>
+      <p:sp>
+        <p:nvSpPr>
+          <p:cNvPr id="30" name="TextBox 29"/>
           <p:cNvSpPr txBox="1"/>
           <p:nvPr/>
         </p:nvSpPr>
         <p:spPr>
           <a:xfrm>
-            <a:off x="6643053" y="3337559"/>
-            <a:ext cx="274320" cy="274320"/>
+            <a:off x="5486400" y="3291840"/>
+            <a:ext cx="2011680" cy="914400"/>
           </a:xfrm>
           <a:prstGeom prst="rect">
             <a:avLst/>
@@ -14472,16 +14740,591 @@
             <a:spAutoFit/>
           </a:bodyPr>
           <a:lstStyle/>
-          <a:p>
-            <a:pPr lvl="0" algn="l">
-              <a:defRPr/>
+          <a:p/>
+          <a:p>
+            <a:pPr>
+              <a:defRPr sz="1200"/>
             </a:pPr>
-            <a:endParaRPr sz="1200" b="1">
-              <a:solidFill>
-                <a:srgbClr val="00c853"/>
-              </a:solidFill>
-              <a:latin typeface="Segoe UI Symbol"/>
-            </a:endParaRPr>
+            <a:r>
+              <a:t>• Safe State Policy</a:t>
+            </a:r>
+            <a:br/>
+            <a:r>
+              <a:t>• SAFE_LOCKED (ON)</a:t>
+            </a:r>
+          </a:p>
+        </p:txBody>
+      </p:sp>
+      <p:sp>
+        <p:nvSpPr>
+          <p:cNvPr id="31" name="TextBox 30"/>
+          <p:cNvSpPr txBox="1"/>
+          <p:nvPr/>
+        </p:nvSpPr>
+        <p:spPr>
+          <a:xfrm>
+            <a:off x="7680960" y="1371600"/>
+            <a:ext cx="4114800" cy="457200"/>
+          </a:xfrm>
+          <a:prstGeom prst="rect">
+            <a:avLst/>
+          </a:prstGeom>
+          <a:noFill/>
+        </p:spPr>
+        <p:txBody>
+          <a:bodyPr wrap="none">
+            <a:spAutoFit/>
+          </a:bodyPr>
+          <a:lstStyle/>
+          <a:p>
+            <a:pPr>
+              <a:defRPr b="1" sz="2200">
+                <a:solidFill>
+                  <a:srgbClr val="003366"/>
+                </a:solidFill>
+              </a:defRPr>
+            </a:pPr>
+            <a:r>
+              <a:t>핵심 로직 (Core Logic)</a:t>
+            </a:r>
+          </a:p>
+        </p:txBody>
+      </p:sp>
+      <p:sp>
+        <p:nvSpPr>
+          <p:cNvPr id="32" name="Rectangle 31"/>
+          <p:cNvSpPr/>
+          <p:nvPr/>
+        </p:nvSpPr>
+        <p:spPr>
+          <a:xfrm>
+            <a:off x="7680960" y="2011680"/>
+            <a:ext cx="4297680" cy="3840480"/>
+          </a:xfrm>
+          <a:prstGeom prst="rect">
+            <a:avLst/>
+          </a:prstGeom>
+          <a:solidFill>
+            <a:srgbClr val="1E1E1E"/>
+          </a:solidFill>
+          <a:ln>
+            <a:solidFill>
+              <a:srgbClr val="505050"/>
+            </a:solidFill>
+          </a:ln>
+        </p:spPr>
+        <p:style>
+          <a:lnRef idx="1">
+            <a:schemeClr val="accent1"/>
+          </a:lnRef>
+          <a:fillRef idx="3">
+            <a:schemeClr val="accent1"/>
+          </a:fillRef>
+          <a:effectRef idx="2">
+            <a:schemeClr val="accent1"/>
+          </a:effectRef>
+          <a:fontRef idx="minor">
+            <a:schemeClr val="lt1"/>
+          </a:fontRef>
+        </p:style>
+        <p:txBody>
+          <a:bodyPr rtlCol="0" anchor="ctr" wrap="none"/>
+          <a:lstStyle/>
+          <a:p>
+            <a:pPr algn="l">
+              <a:spcBef>
+                <a:spcPts val="0"/>
+              </a:spcBef>
+              <a:spcAft>
+                <a:spcPts val="200"/>
+              </a:spcAft>
+            </a:pPr>
+            <a:r>
+              <a:rPr sz="1100">
+                <a:solidFill>
+                  <a:srgbClr val="57A64A"/>
+                </a:solidFill>
+                <a:latin typeface="Consolas"/>
+              </a:rPr>
+              <a:t>/* F-07: Rear Risk Evaluation */</a:t>
+            </a:r>
+          </a:p>
+          <a:p>
+            <a:pPr algn="l">
+              <a:spcBef>
+                <a:spcPts val="0"/>
+              </a:spcBef>
+              <a:spcAft>
+                <a:spcPts val="200"/>
+              </a:spcAft>
+            </a:pPr>
+            <a:r>
+              <a:rPr sz="1100">
+                <a:solidFill>
+                  <a:srgbClr val="569CD6"/>
+                </a:solidFill>
+                <a:latin typeface="Consolas"/>
+              </a:rPr>
+              <a:t>bool</a:t>
+            </a:r>
+            <a:r>
+              <a:rPr sz="1100">
+                <a:solidFill>
+                  <a:srgbClr val="D4D4D4"/>
+                </a:solidFill>
+                <a:latin typeface="Consolas"/>
+              </a:rPr>
+              <a:t> isRawThreatActive(const RiskIn_t *in){</a:t>
+            </a:r>
+          </a:p>
+          <a:p>
+            <a:pPr algn="l">
+              <a:spcBef>
+                <a:spcPts val="0"/>
+              </a:spcBef>
+              <a:spcAft>
+                <a:spcPts val="200"/>
+              </a:spcAft>
+            </a:pPr>
+            <a:r>
+              <a:rPr sz="1100">
+                <a:solidFill>
+                  <a:srgbClr val="569CD6"/>
+                </a:solidFill>
+                <a:latin typeface="Consolas"/>
+              </a:rPr>
+              <a:t>    const </a:t>
+            </a:r>
+            <a:r>
+              <a:rPr sz="1100">
+                <a:solidFill>
+                  <a:srgbClr val="569CD6"/>
+                </a:solidFill>
+                <a:latin typeface="Consolas"/>
+              </a:rPr>
+              <a:t>bool</a:t>
+            </a:r>
+            <a:r>
+              <a:rPr sz="1100">
+                <a:solidFill>
+                  <a:srgbClr val="D4D4D4"/>
+                </a:solidFill>
+                <a:latin typeface="Consolas"/>
+              </a:rPr>
+              <a:t> isClose = (in-&gt;dist &lt;= THRESH);</a:t>
+            </a:r>
+          </a:p>
+          <a:p>
+            <a:pPr algn="l">
+              <a:spcBef>
+                <a:spcPts val="0"/>
+              </a:spcBef>
+              <a:spcAft>
+                <a:spcPts val="200"/>
+              </a:spcAft>
+            </a:pPr>
+            <a:r>
+              <a:rPr sz="1100">
+                <a:solidFill>
+                  <a:srgbClr val="569CD6"/>
+                </a:solidFill>
+                <a:latin typeface="Consolas"/>
+              </a:rPr>
+              <a:t>    const </a:t>
+            </a:r>
+            <a:r>
+              <a:rPr sz="1100">
+                <a:solidFill>
+                  <a:srgbClr val="569CD6"/>
+                </a:solidFill>
+                <a:latin typeface="Consolas"/>
+              </a:rPr>
+              <a:t>bool</a:t>
+            </a:r>
+            <a:r>
+              <a:rPr sz="1100">
+                <a:solidFill>
+                  <a:srgbClr val="D4D4D4"/>
+                </a:solidFill>
+                <a:latin typeface="Consolas"/>
+              </a:rPr>
+              <a:t> isFast = (in-&gt;spd &gt;= THRESH);</a:t>
+            </a:r>
+          </a:p>
+          <a:p>
+            <a:pPr algn="l">
+              <a:spcBef>
+                <a:spcPts val="0"/>
+              </a:spcBef>
+              <a:spcAft>
+                <a:spcPts val="200"/>
+              </a:spcAft>
+            </a:pPr>
+            <a:r>
+              <a:rPr sz="1100">
+                <a:solidFill>
+                  <a:srgbClr val="569CD6"/>
+                </a:solidFill>
+                <a:latin typeface="Consolas"/>
+              </a:rPr>
+              <a:t>    return</a:t>
+            </a:r>
+            <a:r>
+              <a:rPr sz="1100">
+                <a:solidFill>
+                  <a:srgbClr val="D4D4D4"/>
+                </a:solidFill>
+                <a:latin typeface="Consolas"/>
+              </a:rPr>
+              <a:t> (isClose &amp;&amp; isFast);</a:t>
+            </a:r>
+          </a:p>
+          <a:p>
+            <a:pPr algn="l">
+              <a:spcBef>
+                <a:spcPts val="0"/>
+              </a:spcBef>
+              <a:spcAft>
+                <a:spcPts val="200"/>
+              </a:spcAft>
+            </a:pPr>
+            <a:r>
+              <a:rPr sz="1100">
+                <a:solidFill>
+                  <a:srgbClr val="D4D4D4"/>
+                </a:solidFill>
+                <a:latin typeface="Consolas"/>
+              </a:rPr>
+              <a:t>}</a:t>
+            </a:r>
+          </a:p>
+          <a:p>
+            <a:pPr algn="l">
+              <a:spcBef>
+                <a:spcPts val="0"/>
+              </a:spcBef>
+              <a:spcAft>
+                <a:spcPts val="200"/>
+              </a:spcAft>
+            </a:pPr>
+            <a:r>
+              <a:rPr sz="1100">
+                <a:solidFill>
+                  <a:srgbClr val="D4D4D4"/>
+                </a:solidFill>
+                <a:latin typeface="Consolas"/>
+              </a:rPr>
+              <a:t/>
+            </a:r>
+          </a:p>
+          <a:p>
+            <a:pPr algn="l">
+              <a:spcBef>
+                <a:spcPts val="0"/>
+              </a:spcBef>
+              <a:spcAft>
+                <a:spcPts val="200"/>
+              </a:spcAft>
+            </a:pPr>
+            <a:r>
+              <a:rPr sz="1100">
+                <a:solidFill>
+                  <a:srgbClr val="57A64A"/>
+                </a:solidFill>
+                <a:latin typeface="Consolas"/>
+              </a:rPr>
+              <a:t>/* F-08: Protection Controller */</a:t>
+            </a:r>
+          </a:p>
+          <a:p>
+            <a:pPr algn="l">
+              <a:spcBef>
+                <a:spcPts val="0"/>
+              </a:spcBef>
+              <a:spcAft>
+                <a:spcPts val="200"/>
+              </a:spcAft>
+            </a:pPr>
+            <a:r>
+              <a:rPr sz="1100">
+                <a:solidFill>
+                  <a:srgbClr val="569CD6"/>
+                </a:solidFill>
+                <a:latin typeface="Consolas"/>
+              </a:rPr>
+              <a:t>void</a:t>
+            </a:r>
+            <a:r>
+              <a:rPr sz="1100">
+                <a:solidFill>
+                  <a:srgbClr val="D4D4D4"/>
+                </a:solidFill>
+                <a:latin typeface="Consolas"/>
+              </a:rPr>
+              <a:t> Ctrl_Run(const In_t* in, Out_t* out){</a:t>
+            </a:r>
+          </a:p>
+          <a:p>
+            <a:pPr algn="l">
+              <a:spcBef>
+                <a:spcPts val="0"/>
+              </a:spcBef>
+              <a:spcAft>
+                <a:spcPts val="200"/>
+              </a:spcAft>
+            </a:pPr>
+            <a:r>
+              <a:rPr sz="1100">
+                <a:solidFill>
+                  <a:srgbClr val="569CD6"/>
+                </a:solidFill>
+                <a:latin typeface="Consolas"/>
+              </a:rPr>
+              <a:t>    if</a:t>
+            </a:r>
+            <a:r>
+              <a:rPr sz="1100">
+                <a:solidFill>
+                  <a:srgbClr val="D4D4D4"/>
+                </a:solidFill>
+                <a:latin typeface="Consolas"/>
+              </a:rPr>
+              <a:t> (!in-&gt;riskValid) { </a:t>
+            </a:r>
+            <a:r>
+              <a:rPr sz="1100">
+                <a:solidFill>
+                  <a:srgbClr val="57A64A"/>
+                </a:solidFill>
+                <a:latin typeface="Consolas"/>
+              </a:rPr>
+              <a:t>// Sensor Fault</a:t>
+            </a:r>
+          </a:p>
+          <a:p>
+            <a:pPr algn="l">
+              <a:spcBef>
+                <a:spcPts val="0"/>
+              </a:spcBef>
+              <a:spcAft>
+                <a:spcPts val="200"/>
+              </a:spcAft>
+            </a:pPr>
+            <a:r>
+              <a:rPr sz="1100">
+                <a:solidFill>
+                  <a:srgbClr val="D4D4D4"/>
+                </a:solidFill>
+                <a:latin typeface="Consolas"/>
+              </a:rPr>
+              <a:t>        out-&gt;targetCLState = CL_STATE_ON;</a:t>
+            </a:r>
+          </a:p>
+          <a:p>
+            <a:pPr algn="l">
+              <a:spcBef>
+                <a:spcPts val="0"/>
+              </a:spcBef>
+              <a:spcAft>
+                <a:spcPts val="200"/>
+              </a:spcAft>
+            </a:pPr>
+            <a:r>
+              <a:rPr sz="1100">
+                <a:solidFill>
+                  <a:srgbClr val="D4D4D4"/>
+                </a:solidFill>
+                <a:latin typeface="Consolas"/>
+              </a:rPr>
+              <a:t>        out-&gt;warningSound = </a:t>
+            </a:r>
+            <a:r>
+              <a:rPr sz="1100">
+                <a:solidFill>
+                  <a:srgbClr val="569CD6"/>
+                </a:solidFill>
+                <a:latin typeface="Consolas"/>
+              </a:rPr>
+              <a:t>true</a:t>
+            </a:r>
+            <a:r>
+              <a:rPr sz="1100">
+                <a:solidFill>
+                  <a:srgbClr val="D4D4D4"/>
+                </a:solidFill>
+                <a:latin typeface="Consolas"/>
+              </a:rPr>
+              <a:t>;</a:t>
+            </a:r>
+          </a:p>
+          <a:p>
+            <a:pPr algn="l">
+              <a:spcBef>
+                <a:spcPts val="0"/>
+              </a:spcBef>
+              <a:spcAft>
+                <a:spcPts val="200"/>
+              </a:spcAft>
+            </a:pPr>
+            <a:r>
+              <a:rPr sz="1100">
+                <a:solidFill>
+                  <a:srgbClr val="D4D4D4"/>
+                </a:solidFill>
+                <a:latin typeface="Consolas"/>
+              </a:rPr>
+              <a:t>    }</a:t>
+            </a:r>
+          </a:p>
+          <a:p>
+            <a:pPr algn="l">
+              <a:spcBef>
+                <a:spcPts val="0"/>
+              </a:spcBef>
+              <a:spcAft>
+                <a:spcPts val="200"/>
+              </a:spcAft>
+            </a:pPr>
+            <a:r>
+              <a:rPr sz="1100">
+                <a:solidFill>
+                  <a:srgbClr val="569CD6"/>
+                </a:solidFill>
+                <a:latin typeface="Consolas"/>
+              </a:rPr>
+              <a:t>    else if</a:t>
+            </a:r>
+            <a:r>
+              <a:rPr sz="1100">
+                <a:solidFill>
+                  <a:srgbClr val="D4D4D4"/>
+                </a:solidFill>
+                <a:latin typeface="Consolas"/>
+              </a:rPr>
+              <a:t> (in-&gt;riskHigh) { </a:t>
+            </a:r>
+            <a:r>
+              <a:rPr sz="1100">
+                <a:solidFill>
+                  <a:srgbClr val="57A64A"/>
+                </a:solidFill>
+                <a:latin typeface="Consolas"/>
+              </a:rPr>
+              <a:t>// Danger Detected</a:t>
+            </a:r>
+          </a:p>
+          <a:p>
+            <a:pPr algn="l">
+              <a:spcBef>
+                <a:spcPts val="0"/>
+              </a:spcBef>
+              <a:spcAft>
+                <a:spcPts val="200"/>
+              </a:spcAft>
+            </a:pPr>
+            <a:r>
+              <a:rPr sz="1100">
+                <a:solidFill>
+                  <a:srgbClr val="D4D4D4"/>
+                </a:solidFill>
+                <a:latin typeface="Consolas"/>
+              </a:rPr>
+              <a:t>        out-&gt;targetCLState = CL_STATE_ON;</a:t>
+            </a:r>
+          </a:p>
+          <a:p>
+            <a:pPr algn="l">
+              <a:spcBef>
+                <a:spcPts val="0"/>
+              </a:spcBef>
+              <a:spcAft>
+                <a:spcPts val="200"/>
+              </a:spcAft>
+            </a:pPr>
+            <a:r>
+              <a:rPr sz="1100">
+                <a:solidFill>
+                  <a:srgbClr val="D4D4D4"/>
+                </a:solidFill>
+                <a:latin typeface="Consolas"/>
+              </a:rPr>
+              <a:t>        out-&gt;warningMsgId = WARNING_RISK_HIGH;</a:t>
+            </a:r>
+          </a:p>
+          <a:p>
+            <a:pPr algn="l">
+              <a:spcBef>
+                <a:spcPts val="0"/>
+              </a:spcBef>
+              <a:spcAft>
+                <a:spcPts val="200"/>
+              </a:spcAft>
+            </a:pPr>
+            <a:r>
+              <a:rPr sz="1100">
+                <a:solidFill>
+                  <a:srgbClr val="D4D4D4"/>
+                </a:solidFill>
+                <a:latin typeface="Consolas"/>
+              </a:rPr>
+              <a:t>        out-&gt;warningSound = </a:t>
+            </a:r>
+            <a:r>
+              <a:rPr sz="1100">
+                <a:solidFill>
+                  <a:srgbClr val="569CD6"/>
+                </a:solidFill>
+                <a:latin typeface="Consolas"/>
+              </a:rPr>
+              <a:t>true</a:t>
+            </a:r>
+            <a:r>
+              <a:rPr sz="1100">
+                <a:solidFill>
+                  <a:srgbClr val="D4D4D4"/>
+                </a:solidFill>
+                <a:latin typeface="Consolas"/>
+              </a:rPr>
+              <a:t>;</a:t>
+            </a:r>
+          </a:p>
+          <a:p>
+            <a:pPr algn="l">
+              <a:spcBef>
+                <a:spcPts val="0"/>
+              </a:spcBef>
+              <a:spcAft>
+                <a:spcPts val="200"/>
+              </a:spcAft>
+            </a:pPr>
+            <a:r>
+              <a:rPr sz="1100">
+                <a:solidFill>
+                  <a:srgbClr val="D4D4D4"/>
+                </a:solidFill>
+                <a:latin typeface="Consolas"/>
+              </a:rPr>
+              <a:t>    }</a:t>
+            </a:r>
+          </a:p>
+          <a:p>
+            <a:pPr algn="l">
+              <a:spcBef>
+                <a:spcPts val="0"/>
+              </a:spcBef>
+              <a:spcAft>
+                <a:spcPts val="200"/>
+              </a:spcAft>
+            </a:pPr>
+            <a:r>
+              <a:rPr sz="1100">
+                <a:solidFill>
+                  <a:srgbClr val="D4D4D4"/>
+                </a:solidFill>
+                <a:latin typeface="Consolas"/>
+              </a:rPr>
+              <a:t>}</a:t>
+            </a:r>
           </a:p>
         </p:txBody>
       </p:sp>

</xml_diff>

<commit_message>
feat: Programmatically update slide 6 of the presentation with an architecture diagram, flowchart, and code snippet.
</commit_message>
<xml_diff>
--- a/docs/주제1_5팀_PBL최종_제출자료.pptx
+++ b/docs/주제1_5팀_PBL최종_제출자료.pptx
@@ -14377,14 +14377,49 @@
       </p:sp>
       <p:sp>
         <p:nvSpPr>
-          <p:cNvPr id="23" name="Rounded Rectangle 22"/>
+          <p:cNvPr id="31" name="TextBox 30"/>
+          <p:cNvSpPr txBox="1"/>
+          <p:nvPr/>
+        </p:nvSpPr>
+        <p:spPr>
+          <a:xfrm>
+            <a:off x="7680960" y="1371600"/>
+            <a:ext cx="4114800" cy="457200"/>
+          </a:xfrm>
+          <a:prstGeom prst="rect">
+            <a:avLst/>
+          </a:prstGeom>
+          <a:noFill/>
+        </p:spPr>
+        <p:txBody>
+          <a:bodyPr wrap="none">
+            <a:spAutoFit/>
+          </a:bodyPr>
+          <a:lstStyle/>
+          <a:p>
+            <a:pPr>
+              <a:defRPr b="1" sz="2200">
+                <a:solidFill>
+                  <a:srgbClr val="003366"/>
+                </a:solidFill>
+              </a:defRPr>
+            </a:pPr>
+            <a:r>
+              <a:t>핵심 로직 (Core Logic)</a:t>
+            </a:r>
+          </a:p>
+        </p:txBody>
+      </p:sp>
+      <p:sp>
+        <p:nvSpPr>
+          <p:cNvPr id="32" name="Rounded Rectangle 31"/>
           <p:cNvSpPr/>
           <p:nvPr/>
         </p:nvSpPr>
         <p:spPr>
           <a:xfrm>
-            <a:off x="457200" y="2286000"/>
-            <a:ext cx="1828800" cy="914400"/>
+            <a:off x="457200" y="2011680"/>
+            <a:ext cx="1645920" cy="731520"/>
           </a:xfrm>
           <a:prstGeom prst="roundRect">
             <a:avLst/>
@@ -14416,77 +14451,41 @@
           <a:bodyPr rtlCol="0" anchor="ctr"/>
           <a:lstStyle/>
           <a:p>
-            <a:pPr>
-              <a:defRPr b="1" sz="1400">
+            <a:pPr algn="ctr">
+              <a:defRPr b="1" sz="1300">
                 <a:solidFill>
                   <a:srgbClr val="000000"/>
                 </a:solidFill>
               </a:defRPr>
             </a:pPr>
             <a:r>
-              <a:t>데이터 입력 (Sensor)</a:t>
-            </a:r>
-          </a:p>
-          <a:p>
-            <a:pPr>
-              <a:defRPr sz="1200">
+              <a:t>[인지]</a:t>
+            </a:r>
+          </a:p>
+          <a:p>
+            <a:pPr algn="ctr">
+              <a:defRPr sz="1100">
                 <a:solidFill>
                   <a:srgbClr val="000000"/>
                 </a:solidFill>
               </a:defRPr>
             </a:pPr>
             <a:r>
-              <a:t>Radar / Ultrasonic</a:t>
-            </a:r>
-          </a:p>
-        </p:txBody>
-      </p:sp>
-      <p:sp>
-        <p:nvSpPr>
-          <p:cNvPr id="24" name="TextBox 23"/>
-          <p:cNvSpPr txBox="1"/>
-          <p:nvPr/>
-        </p:nvSpPr>
-        <p:spPr>
-          <a:xfrm>
-            <a:off x="365760" y="3291840"/>
-            <a:ext cx="2011680" cy="914400"/>
-          </a:xfrm>
-          <a:prstGeom prst="rect">
-            <a:avLst/>
-          </a:prstGeom>
-          <a:noFill/>
-        </p:spPr>
-        <p:txBody>
-          <a:bodyPr wrap="square">
-            <a:spAutoFit/>
-          </a:bodyPr>
-          <a:lstStyle/>
-          <a:p/>
-          <a:p>
-            <a:pPr>
-              <a:defRPr sz="1200"/>
-            </a:pPr>
-            <a:r>
-              <a:t>• ISO 26262 ASIL B</a:t>
-            </a:r>
-            <a:br/>
-            <a:r>
-              <a:t>• HW Fault Detection</a:t>
-            </a:r>
-          </a:p>
-        </p:txBody>
-      </p:sp>
-      <p:sp>
-        <p:nvSpPr>
-          <p:cNvPr id="25" name="Right Arrow 24"/>
+              <a:t>데이터 입력 (Sensor)</a:t>
+            </a:r>
+          </a:p>
+        </p:txBody>
+      </p:sp>
+      <p:sp>
+        <p:nvSpPr>
+          <p:cNvPr id="33" name="Right Arrow 32"/>
           <p:cNvSpPr/>
           <p:nvPr/>
         </p:nvSpPr>
         <p:spPr>
           <a:xfrm>
-            <a:off x="2377440" y="2560320"/>
-            <a:ext cx="548640" cy="365760"/>
+            <a:off x="2194560" y="2286000"/>
+            <a:ext cx="365760" cy="182880"/>
           </a:xfrm>
           <a:prstGeom prst="rightArrow">
             <a:avLst/>
@@ -14516,14 +14515,14 @@
       </p:sp>
       <p:sp>
         <p:nvSpPr>
-          <p:cNvPr id="26" name="Rounded Rectangle 25"/>
+          <p:cNvPr id="34" name="Rounded Rectangle 33"/>
           <p:cNvSpPr/>
           <p:nvPr/>
         </p:nvSpPr>
         <p:spPr>
           <a:xfrm>
-            <a:off x="3017520" y="2286000"/>
-            <a:ext cx="1828800" cy="914400"/>
+            <a:off x="2651760" y="2011680"/>
+            <a:ext cx="1828800" cy="731520"/>
           </a:xfrm>
           <a:prstGeom prst="roundRect">
             <a:avLst/>
@@ -14555,20 +14554,20 @@
           <a:bodyPr rtlCol="0" anchor="ctr"/>
           <a:lstStyle/>
           <a:p>
-            <a:pPr>
-              <a:defRPr b="1" sz="1400">
+            <a:pPr algn="ctr">
+              <a:defRPr b="1" sz="1300">
                 <a:solidFill>
                   <a:srgbClr val="000000"/>
                 </a:solidFill>
               </a:defRPr>
             </a:pPr>
             <a:r>
-              <a:t>제어 판단 (ECU)</a:t>
-            </a:r>
-          </a:p>
-          <a:p>
-            <a:pPr>
-              <a:defRPr sz="1200">
+              <a:t>[판단]</a:t>
+            </a:r>
+          </a:p>
+          <a:p>
+            <a:pPr algn="ctr">
+              <a:defRPr sz="1100">
                 <a:solidFill>
                   <a:srgbClr val="000000"/>
                 </a:solidFill>
@@ -14582,50 +14581,14 @@
       </p:sp>
       <p:sp>
         <p:nvSpPr>
-          <p:cNvPr id="27" name="TextBox 26"/>
-          <p:cNvSpPr txBox="1"/>
-          <p:nvPr/>
-        </p:nvSpPr>
-        <p:spPr>
-          <a:xfrm>
-            <a:off x="2926080" y="3291840"/>
-            <a:ext cx="2011680" cy="914400"/>
-          </a:xfrm>
-          <a:prstGeom prst="rect">
-            <a:avLst/>
-          </a:prstGeom>
-          <a:noFill/>
-        </p:spPr>
-        <p:txBody>
-          <a:bodyPr wrap="square">
-            <a:spAutoFit/>
-          </a:bodyPr>
-          <a:lstStyle/>
-          <a:p/>
-          <a:p>
-            <a:pPr>
-              <a:defRPr sz="1200"/>
-            </a:pPr>
-            <a:r>
-              <a:t>• A-SPICE SWE.2</a:t>
-            </a:r>
-            <a:br/>
-            <a:r>
-              <a:t>• Risk Eval &amp; Protection</a:t>
-            </a:r>
-          </a:p>
-        </p:txBody>
-      </p:sp>
-      <p:sp>
-        <p:nvSpPr>
-          <p:cNvPr id="28" name="Right Arrow 27"/>
+          <p:cNvPr id="35" name="Right Arrow 34"/>
           <p:cNvSpPr/>
           <p:nvPr/>
         </p:nvSpPr>
         <p:spPr>
           <a:xfrm>
-            <a:off x="4937760" y="2560320"/>
-            <a:ext cx="548640" cy="365760"/>
+            <a:off x="4572000" y="2286000"/>
+            <a:ext cx="365760" cy="182880"/>
           </a:xfrm>
           <a:prstGeom prst="rightArrow">
             <a:avLst/>
@@ -14655,14 +14618,14 @@
       </p:sp>
       <p:sp>
         <p:nvSpPr>
-          <p:cNvPr id="29" name="Rounded Rectangle 28"/>
+          <p:cNvPr id="36" name="Rounded Rectangle 35"/>
           <p:cNvSpPr/>
           <p:nvPr/>
         </p:nvSpPr>
         <p:spPr>
           <a:xfrm>
-            <a:off x="5577840" y="2286000"/>
-            <a:ext cx="1828800" cy="914400"/>
+            <a:off x="5029200" y="2011680"/>
+            <a:ext cx="1645920" cy="731520"/>
           </a:xfrm>
           <a:prstGeom prst="roundRect">
             <a:avLst/>
@@ -14694,20 +14657,20 @@
           <a:bodyPr rtlCol="0" anchor="ctr"/>
           <a:lstStyle/>
           <a:p>
-            <a:pPr>
-              <a:defRPr b="1" sz="1400">
+            <a:pPr algn="ctr">
+              <a:defRPr b="1" sz="1300">
                 <a:solidFill>
                   <a:srgbClr val="000000"/>
                 </a:solidFill>
               </a:defRPr>
             </a:pPr>
             <a:r>
-              <a:t>최종 출력 (Actuator)</a:t>
-            </a:r>
-          </a:p>
-          <a:p>
-            <a:pPr>
-              <a:defRPr sz="1200">
+              <a:t>[제어]</a:t>
+            </a:r>
+          </a:p>
+          <a:p>
+            <a:pPr algn="ctr">
+              <a:defRPr sz="1100">
                 <a:solidFill>
                   <a:srgbClr val="000000"/>
                 </a:solidFill>
@@ -14721,50 +14684,191 @@
       </p:sp>
       <p:sp>
         <p:nvSpPr>
-          <p:cNvPr id="30" name="TextBox 29"/>
+          <p:cNvPr id="37" name="Oval 36"/>
+          <p:cNvSpPr/>
+          <p:nvPr/>
+        </p:nvSpPr>
+        <p:spPr>
+          <a:xfrm>
+            <a:off x="2560320" y="3291840"/>
+            <a:ext cx="1097280" cy="457200"/>
+          </a:xfrm>
+          <a:prstGeom prst="ellipse">
+            <a:avLst/>
+          </a:prstGeom>
+          <a:solidFill>
+            <a:srgbClr val="C8C8C8"/>
+          </a:solidFill>
+        </p:spPr>
+        <p:style>
+          <a:lnRef idx="1">
+            <a:schemeClr val="accent1"/>
+          </a:lnRef>
+          <a:fillRef idx="3">
+            <a:schemeClr val="accent1"/>
+          </a:fillRef>
+          <a:effectRef idx="2">
+            <a:schemeClr val="accent1"/>
+          </a:effectRef>
+          <a:fontRef idx="minor">
+            <a:schemeClr val="lt1"/>
+          </a:fontRef>
+        </p:style>
+        <p:txBody>
+          <a:bodyPr rtlCol="0" anchor="ctr"/>
+          <a:lstStyle/>
+          <a:p>
+            <a:pPr algn="ctr">
+              <a:defRPr sz="1200">
+                <a:solidFill>
+                  <a:srgbClr val="000000"/>
+                </a:solidFill>
+              </a:defRPr>
+            </a:pPr>
+            <a:r>
+              <a:t>주행 중</a:t>
+            </a:r>
+          </a:p>
+        </p:txBody>
+      </p:sp>
+      <p:sp>
+        <p:nvSpPr>
+          <p:cNvPr id="38" name="Down Arrow 37"/>
+          <p:cNvSpPr/>
+          <p:nvPr/>
+        </p:nvSpPr>
+        <p:spPr>
+          <a:xfrm>
+            <a:off x="3017520" y="3749039"/>
+            <a:ext cx="182880" cy="274320"/>
+          </a:xfrm>
+          <a:prstGeom prst="downArrow">
+            <a:avLst/>
+          </a:prstGeom>
+        </p:spPr>
+        <p:style>
+          <a:lnRef idx="1">
+            <a:schemeClr val="accent1"/>
+          </a:lnRef>
+          <a:fillRef idx="3">
+            <a:schemeClr val="accent1"/>
+          </a:fillRef>
+          <a:effectRef idx="2">
+            <a:schemeClr val="accent1"/>
+          </a:effectRef>
+          <a:fontRef idx="minor">
+            <a:schemeClr val="lt1"/>
+          </a:fontRef>
+        </p:style>
+        <p:txBody>
+          <a:bodyPr rtlCol="0" anchor="ctr"/>
+          <a:lstStyle/>
+          <a:p>
+            <a:pPr algn="ctr"/>
+          </a:p>
+        </p:txBody>
+      </p:sp>
+      <p:sp>
+        <p:nvSpPr>
+          <p:cNvPr id="39" name="Diamond 38"/>
+          <p:cNvSpPr/>
+          <p:nvPr/>
+        </p:nvSpPr>
+        <p:spPr>
+          <a:xfrm>
+            <a:off x="2011680" y="4114800"/>
+            <a:ext cx="2194560" cy="914400"/>
+          </a:xfrm>
+          <a:prstGeom prst="diamond">
+            <a:avLst/>
+          </a:prstGeom>
+          <a:solidFill>
+            <a:srgbClr val="FFFFCC"/>
+          </a:solidFill>
+        </p:spPr>
+        <p:style>
+          <a:lnRef idx="1">
+            <a:schemeClr val="accent1"/>
+          </a:lnRef>
+          <a:fillRef idx="3">
+            <a:schemeClr val="accent1"/>
+          </a:fillRef>
+          <a:effectRef idx="2">
+            <a:schemeClr val="accent1"/>
+          </a:effectRef>
+          <a:fontRef idx="minor">
+            <a:schemeClr val="lt1"/>
+          </a:fontRef>
+        </p:style>
+        <p:txBody>
+          <a:bodyPr rtlCol="0" anchor="ctr"/>
+          <a:lstStyle/>
+          <a:p>
+            <a:pPr algn="ctr">
+              <a:defRPr sz="1100">
+                <a:solidFill>
+                  <a:srgbClr val="000000"/>
+                </a:solidFill>
+              </a:defRPr>
+            </a:pPr>
+            <a:r>
+              <a:t>센서 정상</a:t>
+            </a:r>
+          </a:p>
+          <a:p>
+            <a:r>
+              <a:t>(riskValid)</a:t>
+            </a:r>
+          </a:p>
+        </p:txBody>
+      </p:sp>
+      <p:sp>
+        <p:nvSpPr>
+          <p:cNvPr id="40" name="Right Arrow 39"/>
+          <p:cNvSpPr/>
+          <p:nvPr/>
+        </p:nvSpPr>
+        <p:spPr>
+          <a:xfrm>
+            <a:off x="4206240" y="4434840"/>
+            <a:ext cx="548640" cy="182880"/>
+          </a:xfrm>
+          <a:prstGeom prst="rightArrow">
+            <a:avLst/>
+          </a:prstGeom>
+        </p:spPr>
+        <p:style>
+          <a:lnRef idx="1">
+            <a:schemeClr val="accent1"/>
+          </a:lnRef>
+          <a:fillRef idx="3">
+            <a:schemeClr val="accent1"/>
+          </a:fillRef>
+          <a:effectRef idx="2">
+            <a:schemeClr val="accent1"/>
+          </a:effectRef>
+          <a:fontRef idx="minor">
+            <a:schemeClr val="lt1"/>
+          </a:fontRef>
+        </p:style>
+        <p:txBody>
+          <a:bodyPr rtlCol="0" anchor="ctr"/>
+          <a:lstStyle/>
+          <a:p>
+            <a:pPr algn="ctr"/>
+          </a:p>
+        </p:txBody>
+      </p:sp>
+      <p:sp>
+        <p:nvSpPr>
+          <p:cNvPr id="41" name="TextBox 40"/>
           <p:cNvSpPr txBox="1"/>
           <p:nvPr/>
         </p:nvSpPr>
         <p:spPr>
           <a:xfrm>
-            <a:off x="5486400" y="3291840"/>
-            <a:ext cx="2011680" cy="914400"/>
-          </a:xfrm>
-          <a:prstGeom prst="rect">
-            <a:avLst/>
-          </a:prstGeom>
-          <a:noFill/>
-        </p:spPr>
-        <p:txBody>
-          <a:bodyPr wrap="square">
-            <a:spAutoFit/>
-          </a:bodyPr>
-          <a:lstStyle/>
-          <a:p/>
-          <a:p>
-            <a:pPr>
-              <a:defRPr sz="1200"/>
-            </a:pPr>
-            <a:r>
-              <a:t>• Safe State Policy</a:t>
-            </a:r>
-            <a:br/>
-            <a:r>
-              <a:t>• SAFE_LOCKED (ON)</a:t>
-            </a:r>
-          </a:p>
-        </p:txBody>
-      </p:sp>
-      <p:sp>
-        <p:nvSpPr>
-          <p:cNvPr id="31" name="TextBox 30"/>
-          <p:cNvSpPr txBox="1"/>
-          <p:nvPr/>
-        </p:nvSpPr>
-        <p:spPr>
-          <a:xfrm>
-            <a:off x="7680960" y="1371600"/>
-            <a:ext cx="4114800" cy="457200"/>
+            <a:off x="4206240" y="4206240"/>
+            <a:ext cx="457200" cy="274320"/>
           </a:xfrm>
           <a:prstGeom prst="rect">
             <a:avLst/>
@@ -14777,29 +14881,319 @@
           </a:bodyPr>
           <a:lstStyle/>
           <a:p>
-            <a:pPr>
-              <a:defRPr b="1" sz="2200">
-                <a:solidFill>
-                  <a:srgbClr val="003366"/>
+            <a:r>
+              <a:t>No</a:t>
+            </a:r>
+          </a:p>
+        </p:txBody>
+      </p:sp>
+      <p:sp>
+        <p:nvSpPr>
+          <p:cNvPr id="42" name="Rounded Rectangle 41"/>
+          <p:cNvSpPr/>
+          <p:nvPr/>
+        </p:nvSpPr>
+        <p:spPr>
+          <a:xfrm>
+            <a:off x="4846320" y="4297680"/>
+            <a:ext cx="1828800" cy="548640"/>
+          </a:xfrm>
+          <a:prstGeom prst="roundRect">
+            <a:avLst/>
+          </a:prstGeom>
+          <a:solidFill>
+            <a:srgbClr val="FF9999"/>
+          </a:solidFill>
+        </p:spPr>
+        <p:style>
+          <a:lnRef idx="1">
+            <a:schemeClr val="accent1"/>
+          </a:lnRef>
+          <a:fillRef idx="3">
+            <a:schemeClr val="accent1"/>
+          </a:fillRef>
+          <a:effectRef idx="2">
+            <a:schemeClr val="accent1"/>
+          </a:effectRef>
+          <a:fontRef idx="minor">
+            <a:schemeClr val="lt1"/>
+          </a:fontRef>
+        </p:style>
+        <p:txBody>
+          <a:bodyPr rtlCol="0" anchor="ctr"/>
+          <a:lstStyle/>
+          <a:p>
+            <a:pPr algn="ctr">
+              <a:defRPr sz="1100" b="1">
+                <a:solidFill>
+                  <a:srgbClr val="000000"/>
                 </a:solidFill>
               </a:defRPr>
             </a:pPr>
             <a:r>
-              <a:t>핵심 로직 (Core Logic)</a:t>
-            </a:r>
-          </a:p>
-        </p:txBody>
-      </p:sp>
-      <p:sp>
-        <p:nvSpPr>
-          <p:cNvPr id="32" name="Rectangle 31"/>
+              <a:t>SAFE_LOCKED</a:t>
+            </a:r>
+          </a:p>
+          <a:p>
+            <a:r>
+              <a:t>(강제 잠금 + 경고)</a:t>
+            </a:r>
+          </a:p>
+        </p:txBody>
+      </p:sp>
+      <p:sp>
+        <p:nvSpPr>
+          <p:cNvPr id="43" name="Down Arrow 42"/>
           <p:cNvSpPr/>
           <p:nvPr/>
         </p:nvSpPr>
         <p:spPr>
           <a:xfrm>
-            <a:off x="7680960" y="2011680"/>
-            <a:ext cx="4297680" cy="3840480"/>
+            <a:off x="3017520" y="5029200"/>
+            <a:ext cx="182880" cy="365760"/>
+          </a:xfrm>
+          <a:prstGeom prst="downArrow">
+            <a:avLst/>
+          </a:prstGeom>
+        </p:spPr>
+        <p:style>
+          <a:lnRef idx="1">
+            <a:schemeClr val="accent1"/>
+          </a:lnRef>
+          <a:fillRef idx="3">
+            <a:schemeClr val="accent1"/>
+          </a:fillRef>
+          <a:effectRef idx="2">
+            <a:schemeClr val="accent1"/>
+          </a:effectRef>
+          <a:fontRef idx="minor">
+            <a:schemeClr val="lt1"/>
+          </a:fontRef>
+        </p:style>
+        <p:txBody>
+          <a:bodyPr rtlCol="0" anchor="ctr"/>
+          <a:lstStyle/>
+          <a:p>
+            <a:pPr algn="ctr"/>
+          </a:p>
+        </p:txBody>
+      </p:sp>
+      <p:sp>
+        <p:nvSpPr>
+          <p:cNvPr id="44" name="TextBox 43"/>
+          <p:cNvSpPr txBox="1"/>
+          <p:nvPr/>
+        </p:nvSpPr>
+        <p:spPr>
+          <a:xfrm>
+            <a:off x="3108960" y="5029200"/>
+            <a:ext cx="457200" cy="274320"/>
+          </a:xfrm>
+          <a:prstGeom prst="rect">
+            <a:avLst/>
+          </a:prstGeom>
+          <a:noFill/>
+        </p:spPr>
+        <p:txBody>
+          <a:bodyPr wrap="none">
+            <a:spAutoFit/>
+          </a:bodyPr>
+          <a:lstStyle/>
+          <a:p>
+            <a:r>
+              <a:t>Yes</a:t>
+            </a:r>
+          </a:p>
+        </p:txBody>
+      </p:sp>
+      <p:sp>
+        <p:nvSpPr>
+          <p:cNvPr id="45" name="Diamond 44"/>
+          <p:cNvSpPr/>
+          <p:nvPr/>
+        </p:nvSpPr>
+        <p:spPr>
+          <a:xfrm>
+            <a:off x="1554480" y="5486400"/>
+            <a:ext cx="3108960" cy="1005840"/>
+          </a:xfrm>
+          <a:prstGeom prst="diamond">
+            <a:avLst/>
+          </a:prstGeom>
+          <a:solidFill>
+            <a:srgbClr val="FFE5CC"/>
+          </a:solidFill>
+        </p:spPr>
+        <p:style>
+          <a:lnRef idx="1">
+            <a:schemeClr val="accent1"/>
+          </a:lnRef>
+          <a:fillRef idx="3">
+            <a:schemeClr val="accent1"/>
+          </a:fillRef>
+          <a:effectRef idx="2">
+            <a:schemeClr val="accent1"/>
+          </a:effectRef>
+          <a:fontRef idx="minor">
+            <a:schemeClr val="lt1"/>
+          </a:fontRef>
+        </p:style>
+        <p:txBody>
+          <a:bodyPr rtlCol="0" anchor="ctr"/>
+          <a:lstStyle/>
+          <a:p>
+            <a:pPr algn="ctr">
+              <a:defRPr sz="1100">
+                <a:solidFill>
+                  <a:srgbClr val="000000"/>
+                </a:solidFill>
+              </a:defRPr>
+            </a:pPr>
+            <a:r>
+              <a:t>위험 감지?</a:t>
+            </a:r>
+          </a:p>
+          <a:p>
+            <a:r>
+              <a:t>Dist &lt;= THRESH &amp;&amp;</a:t>
+            </a:r>
+          </a:p>
+          <a:p>
+            <a:r>
+              <a:t>Spd &gt;= THRESH</a:t>
+            </a:r>
+          </a:p>
+        </p:txBody>
+      </p:sp>
+      <p:sp>
+        <p:nvSpPr>
+          <p:cNvPr id="46" name="Right Arrow 45"/>
+          <p:cNvSpPr/>
+          <p:nvPr/>
+        </p:nvSpPr>
+        <p:spPr>
+          <a:xfrm>
+            <a:off x="4663440" y="5852160"/>
+            <a:ext cx="548640" cy="182880"/>
+          </a:xfrm>
+          <a:prstGeom prst="rightArrow">
+            <a:avLst/>
+          </a:prstGeom>
+        </p:spPr>
+        <p:style>
+          <a:lnRef idx="1">
+            <a:schemeClr val="accent1"/>
+          </a:lnRef>
+          <a:fillRef idx="3">
+            <a:schemeClr val="accent1"/>
+          </a:fillRef>
+          <a:effectRef idx="2">
+            <a:schemeClr val="accent1"/>
+          </a:effectRef>
+          <a:fontRef idx="minor">
+            <a:schemeClr val="lt1"/>
+          </a:fontRef>
+        </p:style>
+        <p:txBody>
+          <a:bodyPr rtlCol="0" anchor="ctr"/>
+          <a:lstStyle/>
+          <a:p>
+            <a:pPr algn="ctr"/>
+          </a:p>
+        </p:txBody>
+      </p:sp>
+      <p:sp>
+        <p:nvSpPr>
+          <p:cNvPr id="47" name="TextBox 46"/>
+          <p:cNvSpPr txBox="1"/>
+          <p:nvPr/>
+        </p:nvSpPr>
+        <p:spPr>
+          <a:xfrm>
+            <a:off x="4663440" y="5577840"/>
+            <a:ext cx="457200" cy="274320"/>
+          </a:xfrm>
+          <a:prstGeom prst="rect">
+            <a:avLst/>
+          </a:prstGeom>
+          <a:noFill/>
+        </p:spPr>
+        <p:txBody>
+          <a:bodyPr wrap="none">
+            <a:spAutoFit/>
+          </a:bodyPr>
+          <a:lstStyle/>
+          <a:p>
+            <a:r>
+              <a:t>Yes</a:t>
+            </a:r>
+          </a:p>
+        </p:txBody>
+      </p:sp>
+      <p:sp>
+        <p:nvSpPr>
+          <p:cNvPr id="48" name="Rounded Rectangle 47"/>
+          <p:cNvSpPr/>
+          <p:nvPr/>
+        </p:nvSpPr>
+        <p:spPr>
+          <a:xfrm>
+            <a:off x="5303520" y="5715000"/>
+            <a:ext cx="1371600" cy="548640"/>
+          </a:xfrm>
+          <a:prstGeom prst="roundRect">
+            <a:avLst/>
+          </a:prstGeom>
+          <a:solidFill>
+            <a:srgbClr val="FF6666"/>
+          </a:solidFill>
+        </p:spPr>
+        <p:style>
+          <a:lnRef idx="1">
+            <a:schemeClr val="accent1"/>
+          </a:lnRef>
+          <a:fillRef idx="3">
+            <a:schemeClr val="accent1"/>
+          </a:fillRef>
+          <a:effectRef idx="2">
+            <a:schemeClr val="accent1"/>
+          </a:effectRef>
+          <a:fontRef idx="minor">
+            <a:schemeClr val="lt1"/>
+          </a:fontRef>
+        </p:style>
+        <p:txBody>
+          <a:bodyPr rtlCol="0" anchor="ctr"/>
+          <a:lstStyle/>
+          <a:p>
+            <a:pPr algn="ctr">
+              <a:defRPr sz="1100" b="1">
+                <a:solidFill>
+                  <a:srgbClr val="FFFFFF"/>
+                </a:solidFill>
+              </a:defRPr>
+            </a:pPr>
+            <a:r>
+              <a:t>위험 (Risk High)</a:t>
+            </a:r>
+          </a:p>
+          <a:p>
+            <a:r>
+              <a:t>잠금 유지 + 경고</a:t>
+            </a:r>
+          </a:p>
+        </p:txBody>
+      </p:sp>
+      <p:sp>
+        <p:nvSpPr>
+          <p:cNvPr id="49" name="Rectangle 48"/>
+          <p:cNvSpPr/>
+          <p:nvPr/>
+        </p:nvSpPr>
+        <p:spPr>
+          <a:xfrm>
+            <a:off x="7315200" y="2011680"/>
+            <a:ext cx="4572000" cy="4297680"/>
           </a:xfrm>
           <a:prstGeom prst="rect">
             <a:avLst/>
@@ -14874,7 +15268,7 @@
                 </a:solidFill>
                 <a:latin typeface="Consolas"/>
               </a:rPr>
-              <a:t> isRawThreatActive(const RiskIn_t *in){</a:t>
+              <a:t> isRawThreatActive(const RearRiskInput_t *in){</a:t>
             </a:r>
           </a:p>
           <a:p>
@@ -15061,7 +15455,7 @@
                 </a:solidFill>
                 <a:latin typeface="Consolas"/>
               </a:rPr>
-              <a:t> Ctrl_Run(const In_t* in, Out_t* out){</a:t>
+              <a:t> F08_Run(const Input_t* in, Output_t* out){</a:t>
             </a:r>
           </a:p>
           <a:p>
@@ -15098,7 +15492,7 @@
                 </a:solidFill>
                 <a:latin typeface="Consolas"/>
               </a:rPr>
-              <a:t>// Sensor Fault</a:t>
+              <a:t>// 센서 오류</a:t>
             </a:r>
           </a:p>
           <a:p>
@@ -15210,7 +15604,7 @@
                 </a:solidFill>
                 <a:latin typeface="Consolas"/>
               </a:rPr>
-              <a:t>// Danger Detected</a:t>
+              <a:t>// 위험 단계</a:t>
             </a:r>
           </a:p>
           <a:p>
@@ -15248,7 +15642,25 @@
                 </a:solidFill>
                 <a:latin typeface="Consolas"/>
               </a:rPr>
-              <a:t>        out-&gt;warningMsgId = WARNING_RISK_HIGH;</a:t>
+              <a:t>        out-&gt;warningSound = </a:t>
+            </a:r>
+            <a:r>
+              <a:rPr sz="1100">
+                <a:solidFill>
+                  <a:srgbClr val="569CD6"/>
+                </a:solidFill>
+                <a:latin typeface="Consolas"/>
+              </a:rPr>
+              <a:t>true</a:t>
+            </a:r>
+            <a:r>
+              <a:rPr sz="1100">
+                <a:solidFill>
+                  <a:srgbClr val="D4D4D4"/>
+                </a:solidFill>
+                <a:latin typeface="Consolas"/>
+              </a:rPr>
+              <a:t>;</a:t>
             </a:r>
           </a:p>
           <a:p>
@@ -15267,25 +15679,7 @@
                 </a:solidFill>
                 <a:latin typeface="Consolas"/>
               </a:rPr>
-              <a:t>        out-&gt;warningSound = </a:t>
-            </a:r>
-            <a:r>
-              <a:rPr sz="1100">
-                <a:solidFill>
-                  <a:srgbClr val="569CD6"/>
-                </a:solidFill>
-                <a:latin typeface="Consolas"/>
-              </a:rPr>
-              <a:t>true</a:t>
-            </a:r>
-            <a:r>
-              <a:rPr sz="1100">
-                <a:solidFill>
-                  <a:srgbClr val="D4D4D4"/>
-                </a:solidFill>
-                <a:latin typeface="Consolas"/>
-              </a:rPr>
-              <a:t>;</a:t>
+              <a:t>    }</a:t>
             </a:r>
           </a:p>
           <a:p>
@@ -15304,27 +15698,143 @@
                 </a:solidFill>
                 <a:latin typeface="Consolas"/>
               </a:rPr>
-              <a:t>    }</a:t>
-            </a:r>
-          </a:p>
-          <a:p>
-            <a:pPr algn="l">
-              <a:spcBef>
-                <a:spcPts val="0"/>
-              </a:spcBef>
-              <a:spcAft>
-                <a:spcPts val="200"/>
-              </a:spcAft>
-            </a:pPr>
-            <a:r>
-              <a:rPr sz="1100">
-                <a:solidFill>
-                  <a:srgbClr val="D4D4D4"/>
-                </a:solidFill>
-                <a:latin typeface="Consolas"/>
-              </a:rPr>
               <a:t>}</a:t>
             </a:r>
+          </a:p>
+        </p:txBody>
+      </p:sp>
+      <p:sp>
+        <p:nvSpPr>
+          <p:cNvPr id="50" name="Left Arrow 49"/>
+          <p:cNvSpPr/>
+          <p:nvPr/>
+        </p:nvSpPr>
+        <p:spPr>
+          <a:xfrm>
+            <a:off x="6766560" y="2926080"/>
+            <a:ext cx="548640" cy="274320"/>
+          </a:xfrm>
+          <a:prstGeom prst="leftArrow">
+            <a:avLst/>
+          </a:prstGeom>
+          <a:solidFill>
+            <a:srgbClr val="FFCC00"/>
+          </a:solidFill>
+          <a:ln>
+            <a:solidFill>
+              <a:srgbClr val="FFCC00"/>
+            </a:solidFill>
+          </a:ln>
+        </p:spPr>
+        <p:style>
+          <a:lnRef idx="1">
+            <a:schemeClr val="accent1"/>
+          </a:lnRef>
+          <a:fillRef idx="3">
+            <a:schemeClr val="accent1"/>
+          </a:fillRef>
+          <a:effectRef idx="2">
+            <a:schemeClr val="accent1"/>
+          </a:effectRef>
+          <a:fontRef idx="minor">
+            <a:schemeClr val="lt1"/>
+          </a:fontRef>
+        </p:style>
+        <p:txBody>
+          <a:bodyPr rtlCol="0" anchor="ctr"/>
+          <a:lstStyle/>
+          <a:p>
+            <a:pPr algn="ctr"/>
+          </a:p>
+        </p:txBody>
+      </p:sp>
+      <p:sp>
+        <p:nvSpPr>
+          <p:cNvPr id="51" name="Left Arrow 50"/>
+          <p:cNvSpPr/>
+          <p:nvPr/>
+        </p:nvSpPr>
+        <p:spPr>
+          <a:xfrm>
+            <a:off x="6766560" y="4114800"/>
+            <a:ext cx="548640" cy="274320"/>
+          </a:xfrm>
+          <a:prstGeom prst="leftArrow">
+            <a:avLst/>
+          </a:prstGeom>
+          <a:solidFill>
+            <a:srgbClr val="FF9999"/>
+          </a:solidFill>
+          <a:ln>
+            <a:solidFill>
+              <a:srgbClr val="FF9999"/>
+            </a:solidFill>
+          </a:ln>
+        </p:spPr>
+        <p:style>
+          <a:lnRef idx="1">
+            <a:schemeClr val="accent1"/>
+          </a:lnRef>
+          <a:fillRef idx="3">
+            <a:schemeClr val="accent1"/>
+          </a:fillRef>
+          <a:effectRef idx="2">
+            <a:schemeClr val="accent1"/>
+          </a:effectRef>
+          <a:fontRef idx="minor">
+            <a:schemeClr val="lt1"/>
+          </a:fontRef>
+        </p:style>
+        <p:txBody>
+          <a:bodyPr rtlCol="0" anchor="ctr"/>
+          <a:lstStyle/>
+          <a:p>
+            <a:pPr algn="ctr"/>
+          </a:p>
+        </p:txBody>
+      </p:sp>
+      <p:sp>
+        <p:nvSpPr>
+          <p:cNvPr id="52" name="Left Arrow 51"/>
+          <p:cNvSpPr/>
+          <p:nvPr/>
+        </p:nvSpPr>
+        <p:spPr>
+          <a:xfrm>
+            <a:off x="6766560" y="5120640"/>
+            <a:ext cx="548640" cy="274320"/>
+          </a:xfrm>
+          <a:prstGeom prst="leftArrow">
+            <a:avLst/>
+          </a:prstGeom>
+          <a:solidFill>
+            <a:srgbClr val="FF6666"/>
+          </a:solidFill>
+          <a:ln>
+            <a:solidFill>
+              <a:srgbClr val="FF6666"/>
+            </a:solidFill>
+          </a:ln>
+        </p:spPr>
+        <p:style>
+          <a:lnRef idx="1">
+            <a:schemeClr val="accent1"/>
+          </a:lnRef>
+          <a:fillRef idx="3">
+            <a:schemeClr val="accent1"/>
+          </a:fillRef>
+          <a:effectRef idx="2">
+            <a:schemeClr val="accent1"/>
+          </a:effectRef>
+          <a:fontRef idx="minor">
+            <a:schemeClr val="lt1"/>
+          </a:fontRef>
+        </p:style>
+        <p:txBody>
+          <a:bodyPr rtlCol="0" anchor="ctr"/>
+          <a:lstStyle/>
+          <a:p>
+            <a:pPr algn="ctr"/>
           </a:p>
         </p:txBody>
       </p:sp>

</xml_diff>

<commit_message>
feat: Add Python script to generate slide 6 of the final presentation, including architecture, flowchart, and F-07/F-08 code snippet.
</commit_message>
<xml_diff>
--- a/docs/주제1_5팀_PBL최종_제출자료.pptx
+++ b/docs/주제1_5팀_PBL최종_제출자료.pptx
@@ -14418,8 +14418,8 @@
         </p:nvSpPr>
         <p:spPr>
           <a:xfrm>
-            <a:off x="457200" y="2011680"/>
-            <a:ext cx="1645920" cy="731520"/>
+            <a:off x="457200" y="1828800"/>
+            <a:ext cx="1316736" cy="585216"/>
           </a:xfrm>
           <a:prstGeom prst="roundRect">
             <a:avLst/>
@@ -14452,7 +14452,7 @@
           <a:lstStyle/>
           <a:p>
             <a:pPr algn="ctr">
-              <a:defRPr b="1" sz="1300">
+              <a:defRPr b="1" sz="1100">
                 <a:solidFill>
                   <a:srgbClr val="000000"/>
                 </a:solidFill>
@@ -14464,14 +14464,14 @@
           </a:p>
           <a:p>
             <a:pPr algn="ctr">
-              <a:defRPr sz="1100">
+              <a:defRPr sz="1000">
                 <a:solidFill>
                   <a:srgbClr val="000000"/>
                 </a:solidFill>
               </a:defRPr>
             </a:pPr>
             <a:r>
-              <a:t>데이터 입력 (Sensor)</a:t>
+              <a:t>데이터 입력</a:t>
             </a:r>
           </a:p>
         </p:txBody>
@@ -14484,8 +14484,8 @@
         </p:nvSpPr>
         <p:spPr>
           <a:xfrm>
-            <a:off x="2194560" y="2286000"/>
-            <a:ext cx="365760" cy="182880"/>
+            <a:off x="1819656" y="2029968"/>
+            <a:ext cx="274320" cy="182880"/>
           </a:xfrm>
           <a:prstGeom prst="rightArrow">
             <a:avLst/>
@@ -14521,8 +14521,8 @@
         </p:nvSpPr>
         <p:spPr>
           <a:xfrm>
-            <a:off x="2651760" y="2011680"/>
-            <a:ext cx="1828800" cy="731520"/>
+            <a:off x="2139696" y="1828800"/>
+            <a:ext cx="1499616" cy="585216"/>
           </a:xfrm>
           <a:prstGeom prst="roundRect">
             <a:avLst/>
@@ -14555,7 +14555,7 @@
           <a:lstStyle/>
           <a:p>
             <a:pPr algn="ctr">
-              <a:defRPr b="1" sz="1300">
+              <a:defRPr b="1" sz="1100">
                 <a:solidFill>
                   <a:srgbClr val="000000"/>
                 </a:solidFill>
@@ -14567,7 +14567,7 @@
           </a:p>
           <a:p>
             <a:pPr algn="ctr">
-              <a:defRPr sz="1100">
+              <a:defRPr sz="1000">
                 <a:solidFill>
                   <a:srgbClr val="000000"/>
                 </a:solidFill>
@@ -14587,8 +14587,8 @@
         </p:nvSpPr>
         <p:spPr>
           <a:xfrm>
-            <a:off x="4572000" y="2286000"/>
-            <a:ext cx="365760" cy="182880"/>
+            <a:off x="3685032" y="2029968"/>
+            <a:ext cx="274320" cy="182880"/>
           </a:xfrm>
           <a:prstGeom prst="rightArrow">
             <a:avLst/>
@@ -14624,8 +14624,8 @@
         </p:nvSpPr>
         <p:spPr>
           <a:xfrm>
-            <a:off x="5029200" y="2011680"/>
-            <a:ext cx="1645920" cy="731520"/>
+            <a:off x="4005072" y="1828800"/>
+            <a:ext cx="1316736" cy="585216"/>
           </a:xfrm>
           <a:prstGeom prst="roundRect">
             <a:avLst/>
@@ -14658,7 +14658,7 @@
           <a:lstStyle/>
           <a:p>
             <a:pPr algn="ctr">
-              <a:defRPr b="1" sz="1300">
+              <a:defRPr b="1" sz="1100">
                 <a:solidFill>
                   <a:srgbClr val="000000"/>
                 </a:solidFill>
@@ -14670,7 +14670,7 @@
           </a:p>
           <a:p>
             <a:pPr algn="ctr">
-              <a:defRPr sz="1100">
+              <a:defRPr sz="1000">
                 <a:solidFill>
                   <a:srgbClr val="000000"/>
                 </a:solidFill>
@@ -14690,8 +14690,8 @@
         </p:nvSpPr>
         <p:spPr>
           <a:xfrm>
-            <a:off x="2560320" y="3291840"/>
-            <a:ext cx="1097280" cy="457200"/>
+            <a:off x="2487168" y="2651760"/>
+            <a:ext cx="877824" cy="365760"/>
           </a:xfrm>
           <a:prstGeom prst="ellipse">
             <a:avLst/>
@@ -14719,14 +14719,14 @@
           <a:lstStyle/>
           <a:p>
             <a:pPr algn="ctr">
-              <a:defRPr sz="1200">
+              <a:defRPr sz="1100">
                 <a:solidFill>
                   <a:srgbClr val="000000"/>
                 </a:solidFill>
               </a:defRPr>
             </a:pPr>
             <a:r>
-              <a:t>주행 중</a:t>
+              <a:t>정차 중</a:t>
             </a:r>
           </a:p>
         </p:txBody>
@@ -14739,8 +14739,8 @@
         </p:nvSpPr>
         <p:spPr>
           <a:xfrm>
-            <a:off x="3017520" y="3749039"/>
-            <a:ext cx="182880" cy="274320"/>
+            <a:off x="2834640" y="3017520"/>
+            <a:ext cx="182880" cy="320040"/>
           </a:xfrm>
           <a:prstGeom prst="downArrow">
             <a:avLst/>
@@ -14776,8 +14776,8 @@
         </p:nvSpPr>
         <p:spPr>
           <a:xfrm>
-            <a:off x="2011680" y="4114800"/>
-            <a:ext cx="2194560" cy="914400"/>
+            <a:off x="2048256" y="3337560"/>
+            <a:ext cx="1755648" cy="731520"/>
           </a:xfrm>
           <a:prstGeom prst="diamond">
             <a:avLst/>
@@ -14805,7 +14805,7 @@
           <a:lstStyle/>
           <a:p>
             <a:pPr algn="ctr">
-              <a:defRPr sz="1100">
+              <a:defRPr sz="1000">
                 <a:solidFill>
                   <a:srgbClr val="000000"/>
                 </a:solidFill>
@@ -14830,8 +14830,8 @@
         </p:nvSpPr>
         <p:spPr>
           <a:xfrm>
-            <a:off x="4206240" y="4434840"/>
-            <a:ext cx="548640" cy="182880"/>
+            <a:off x="3803904" y="3611879"/>
+            <a:ext cx="457200" cy="182880"/>
           </a:xfrm>
           <a:prstGeom prst="rightArrow">
             <a:avLst/>
@@ -14867,7 +14867,7 @@
         </p:nvSpPr>
         <p:spPr>
           <a:xfrm>
-            <a:off x="4206240" y="4206240"/>
+            <a:off x="3803904" y="3429000"/>
             <a:ext cx="457200" cy="274320"/>
           </a:xfrm>
           <a:prstGeom prst="rect">
@@ -14881,6 +14881,9 @@
           </a:bodyPr>
           <a:lstStyle/>
           <a:p>
+            <a:pPr>
+              <a:defRPr sz="1000"/>
+            </a:pPr>
             <a:r>
               <a:t>No</a:t>
             </a:r>
@@ -14895,8 +14898,8 @@
         </p:nvSpPr>
         <p:spPr>
           <a:xfrm>
-            <a:off x="4846320" y="4297680"/>
-            <a:ext cx="1828800" cy="548640"/>
+            <a:off x="4352544" y="3483863"/>
+            <a:ext cx="1463040" cy="438912"/>
           </a:xfrm>
           <a:prstGeom prst="roundRect">
             <a:avLst/>
@@ -14924,7 +14927,7 @@
           <a:lstStyle/>
           <a:p>
             <a:pPr algn="ctr">
-              <a:defRPr sz="1100" b="1">
+              <a:defRPr sz="1000" b="1">
                 <a:solidFill>
                   <a:srgbClr val="000000"/>
                 </a:solidFill>
@@ -14949,7 +14952,7 @@
         </p:nvSpPr>
         <p:spPr>
           <a:xfrm>
-            <a:off x="3017520" y="5029200"/>
+            <a:off x="2834640" y="4069080"/>
             <a:ext cx="182880" cy="365760"/>
           </a:xfrm>
           <a:prstGeom prst="downArrow">
@@ -14986,7 +14989,7 @@
         </p:nvSpPr>
         <p:spPr>
           <a:xfrm>
-            <a:off x="3108960" y="5029200"/>
+            <a:off x="3017520" y="4069080"/>
             <a:ext cx="457200" cy="274320"/>
           </a:xfrm>
           <a:prstGeom prst="rect">
@@ -15000,6 +15003,9 @@
           </a:bodyPr>
           <a:lstStyle/>
           <a:p>
+            <a:pPr>
+              <a:defRPr sz="1000"/>
+            </a:pPr>
             <a:r>
               <a:t>Yes</a:t>
             </a:r>
@@ -15014,8 +15020,8 @@
         </p:nvSpPr>
         <p:spPr>
           <a:xfrm>
-            <a:off x="1554480" y="5486400"/>
-            <a:ext cx="3108960" cy="1005840"/>
+            <a:off x="1609344" y="4434840"/>
+            <a:ext cx="2633472" cy="804672"/>
           </a:xfrm>
           <a:prstGeom prst="diamond">
             <a:avLst/>
@@ -15043,7 +15049,7 @@
           <a:lstStyle/>
           <a:p>
             <a:pPr algn="ctr">
-              <a:defRPr sz="1100">
+              <a:defRPr sz="1000">
                 <a:solidFill>
                   <a:srgbClr val="000000"/>
                 </a:solidFill>
@@ -15054,11 +15060,25 @@
             </a:r>
           </a:p>
           <a:p>
-            <a:r>
-              <a:t>Dist &lt;= THRESH &amp;&amp;</a:t>
-            </a:r>
-          </a:p>
-          <a:p>
+            <a:pPr algn="ctr">
+              <a:defRPr sz="1000">
+                <a:solidFill>
+                  <a:srgbClr val="000000"/>
+                </a:solidFill>
+              </a:defRPr>
+            </a:pPr>
+            <a:r>
+              <a:t>Dist &lt;= THRESH</a:t>
+            </a:r>
+          </a:p>
+          <a:p>
+            <a:pPr algn="ctr">
+              <a:defRPr sz="1000">
+                <a:solidFill>
+                  <a:srgbClr val="000000"/>
+                </a:solidFill>
+              </a:defRPr>
+            </a:pPr>
             <a:r>
               <a:t>Spd &gt;= THRESH</a:t>
             </a:r>
@@ -15073,8 +15093,8 @@
         </p:nvSpPr>
         <p:spPr>
           <a:xfrm>
-            <a:off x="4663440" y="5852160"/>
-            <a:ext cx="548640" cy="182880"/>
+            <a:off x="4242816" y="4745736"/>
+            <a:ext cx="457200" cy="182880"/>
           </a:xfrm>
           <a:prstGeom prst="rightArrow">
             <a:avLst/>
@@ -15110,7 +15130,7 @@
         </p:nvSpPr>
         <p:spPr>
           <a:xfrm>
-            <a:off x="4663440" y="5577840"/>
+            <a:off x="4242816" y="4562856"/>
             <a:ext cx="457200" cy="274320"/>
           </a:xfrm>
           <a:prstGeom prst="rect">
@@ -15124,6 +15144,9 @@
           </a:bodyPr>
           <a:lstStyle/>
           <a:p>
+            <a:pPr>
+              <a:defRPr sz="1000"/>
+            </a:pPr>
             <a:r>
               <a:t>Yes</a:t>
             </a:r>
@@ -15138,8 +15161,8 @@
         </p:nvSpPr>
         <p:spPr>
           <a:xfrm>
-            <a:off x="5303520" y="5715000"/>
-            <a:ext cx="1371600" cy="548640"/>
+            <a:off x="4791456" y="4617720"/>
+            <a:ext cx="1463040" cy="438912"/>
           </a:xfrm>
           <a:prstGeom prst="roundRect">
             <a:avLst/>
@@ -15147,6 +15170,11 @@
           <a:solidFill>
             <a:srgbClr val="FF6666"/>
           </a:solidFill>
+          <a:ln>
+            <a:solidFill>
+              <a:srgbClr val="C83232"/>
+            </a:solidFill>
+          </a:ln>
         </p:spPr>
         <p:style>
           <a:lnRef idx="1">
@@ -15167,7 +15195,7 @@
           <a:lstStyle/>
           <a:p>
             <a:pPr algn="ctr">
-              <a:defRPr sz="1100" b="1">
+              <a:defRPr sz="1000" b="1">
                 <a:solidFill>
                   <a:srgbClr val="FFFFFF"/>
                 </a:solidFill>
@@ -15179,14 +15207,141 @@
           </a:p>
           <a:p>
             <a:r>
-              <a:t>잠금 유지 + 경고</a:t>
-            </a:r>
-          </a:p>
-        </p:txBody>
-      </p:sp>
-      <p:sp>
-        <p:nvSpPr>
-          <p:cNvPr id="49" name="Rectangle 48"/>
+              <a:t>잠금 유지+경고</a:t>
+            </a:r>
+          </a:p>
+        </p:txBody>
+      </p:sp>
+      <p:sp>
+        <p:nvSpPr>
+          <p:cNvPr id="49" name="Down Arrow 48"/>
+          <p:cNvSpPr/>
+          <p:nvPr/>
+        </p:nvSpPr>
+        <p:spPr>
+          <a:xfrm>
+            <a:off x="2834640" y="5239512"/>
+            <a:ext cx="182880" cy="365760"/>
+          </a:xfrm>
+          <a:prstGeom prst="downArrow">
+            <a:avLst/>
+          </a:prstGeom>
+        </p:spPr>
+        <p:style>
+          <a:lnRef idx="1">
+            <a:schemeClr val="accent1"/>
+          </a:lnRef>
+          <a:fillRef idx="3">
+            <a:schemeClr val="accent1"/>
+          </a:fillRef>
+          <a:effectRef idx="2">
+            <a:schemeClr val="accent1"/>
+          </a:effectRef>
+          <a:fontRef idx="minor">
+            <a:schemeClr val="lt1"/>
+          </a:fontRef>
+        </p:style>
+        <p:txBody>
+          <a:bodyPr rtlCol="0" anchor="ctr"/>
+          <a:lstStyle/>
+          <a:p>
+            <a:pPr algn="ctr"/>
+          </a:p>
+        </p:txBody>
+      </p:sp>
+      <p:sp>
+        <p:nvSpPr>
+          <p:cNvPr id="50" name="TextBox 49"/>
+          <p:cNvSpPr txBox="1"/>
+          <p:nvPr/>
+        </p:nvSpPr>
+        <p:spPr>
+          <a:xfrm>
+            <a:off x="3017520" y="5239512"/>
+            <a:ext cx="457200" cy="274320"/>
+          </a:xfrm>
+          <a:prstGeom prst="rect">
+            <a:avLst/>
+          </a:prstGeom>
+          <a:noFill/>
+        </p:spPr>
+        <p:txBody>
+          <a:bodyPr wrap="none">
+            <a:spAutoFit/>
+          </a:bodyPr>
+          <a:lstStyle/>
+          <a:p>
+            <a:pPr>
+              <a:defRPr sz="1000"/>
+            </a:pPr>
+            <a:r>
+              <a:t>No</a:t>
+            </a:r>
+          </a:p>
+        </p:txBody>
+      </p:sp>
+      <p:sp>
+        <p:nvSpPr>
+          <p:cNvPr id="51" name="Rounded Rectangle 50"/>
+          <p:cNvSpPr/>
+          <p:nvPr/>
+        </p:nvSpPr>
+        <p:spPr>
+          <a:xfrm>
+            <a:off x="2048256" y="5605272"/>
+            <a:ext cx="1755648" cy="512063"/>
+          </a:xfrm>
+          <a:prstGeom prst="roundRect">
+            <a:avLst/>
+          </a:prstGeom>
+          <a:solidFill>
+            <a:srgbClr val="DCF5DC"/>
+          </a:solidFill>
+          <a:ln>
+            <a:solidFill>
+              <a:srgbClr val="006400"/>
+            </a:solidFill>
+          </a:ln>
+        </p:spPr>
+        <p:style>
+          <a:lnRef idx="1">
+            <a:schemeClr val="accent1"/>
+          </a:lnRef>
+          <a:fillRef idx="3">
+            <a:schemeClr val="accent1"/>
+          </a:fillRef>
+          <a:effectRef idx="2">
+            <a:schemeClr val="accent1"/>
+          </a:effectRef>
+          <a:fontRef idx="minor">
+            <a:schemeClr val="lt1"/>
+          </a:fontRef>
+        </p:style>
+        <p:txBody>
+          <a:bodyPr rtlCol="0" anchor="ctr"/>
+          <a:lstStyle/>
+          <a:p>
+            <a:pPr algn="ctr">
+              <a:defRPr sz="1000" b="1">
+                <a:solidFill>
+                  <a:srgbClr val="006400"/>
+                </a:solidFill>
+              </a:defRPr>
+            </a:pPr>
+            <a:r>
+              <a:t>안전 (Safe)</a:t>
+            </a:r>
+          </a:p>
+          <a:p>
+            <a:r>
+              <a:t>잠금 해제 허용 (하차 가능)</a:t>
+            </a:r>
+          </a:p>
+        </p:txBody>
+      </p:sp>
+      <p:sp>
+        <p:nvSpPr>
+          <p:cNvPr id="52" name="Rectangle 51"/>
           <p:cNvSpPr/>
           <p:nvPr/>
         </p:nvSpPr>
@@ -15705,24 +15860,24 @@
       </p:sp>
       <p:sp>
         <p:nvSpPr>
-          <p:cNvPr id="50" name="Left Arrow 49"/>
+          <p:cNvPr id="53" name="Left Arrow 52"/>
           <p:cNvSpPr/>
           <p:nvPr/>
         </p:nvSpPr>
         <p:spPr>
           <a:xfrm>
-            <a:off x="6766560" y="2926080"/>
+            <a:off x="6766560" y="2651760"/>
             <a:ext cx="548640" cy="274320"/>
           </a:xfrm>
           <a:prstGeom prst="leftArrow">
             <a:avLst/>
           </a:prstGeom>
           <a:solidFill>
-            <a:srgbClr val="FFCC00"/>
+            <a:srgbClr val="C8C8C8"/>
           </a:solidFill>
           <a:ln>
             <a:solidFill>
-              <a:srgbClr val="FFCC00"/>
+              <a:srgbClr val="C8C8C8"/>
             </a:solidFill>
           </a:ln>
         </p:spPr>
@@ -15750,13 +15905,13 @@
       </p:sp>
       <p:sp>
         <p:nvSpPr>
-          <p:cNvPr id="51" name="Left Arrow 50"/>
+          <p:cNvPr id="54" name="Left Arrow 53"/>
           <p:cNvSpPr/>
           <p:nvPr/>
         </p:nvSpPr>
         <p:spPr>
           <a:xfrm>
-            <a:off x="6766560" y="4114800"/>
+            <a:off x="6766560" y="3931920"/>
             <a:ext cx="548640" cy="274320"/>
           </a:xfrm>
           <a:prstGeom prst="leftArrow">
@@ -15795,13 +15950,13 @@
       </p:sp>
       <p:sp>
         <p:nvSpPr>
-          <p:cNvPr id="52" name="Left Arrow 51"/>
+          <p:cNvPr id="55" name="Left Arrow 54"/>
           <p:cNvSpPr/>
           <p:nvPr/>
         </p:nvSpPr>
         <p:spPr>
           <a:xfrm>
-            <a:off x="6766560" y="5120640"/>
+            <a:off x="6766560" y="4846320"/>
             <a:ext cx="548640" cy="274320"/>
           </a:xfrm>
           <a:prstGeom prst="leftArrow">

</xml_diff>